<commit_message>
Site updated: 2020-09-27 20:53:56
</commit_message>
<xml_diff>
--- a/assets/scope-storage.pptx
+++ b/assets/scope-storage.pptx
@@ -325,7 +325,7 @@
       </a:defRPr>
     </a:lvl9pPr>
   </p:defaultTextStyle>
-  <p:modifyVerifier cryptProviderType="rsaFull" cryptAlgorithmClass="hash" cryptAlgorithmType="typeAny" cryptAlgorithmSid="4" spinCount="100000" saltData="k+eapkZsSu5e+w3POuw3tw==" hashData="2hs5H4BRMmGC/l0ljhj56AOnSOw="/>
+  <p:modifyVerifier cryptProviderType="rsaFull" cryptAlgorithmClass="hash" cryptAlgorithmType="typeAny" cryptAlgorithmSid="4" spinCount="100000" saltData="aawHXvGlMSdogV3TOShBlA==" hashData="6HVbfHY/Lwh6WdRmrS/48oBDRpc="/>
 </p:presentation>
 </file>
 
@@ -958,72 +958,6 @@
           <a:bodyPr/>
           <a:lstStyle/>
           <a:p>
-            <a:pPr marL="0" marR="0" lvl="0" indent="0" algn="l" defTabSz="457200" rtl="0" eaLnBrk="1" fontAlgn="auto" latinLnBrk="0" hangingPunct="1">
-              <a:lnSpc>
-                <a:spcPct val="118000"/>
-              </a:lnSpc>
-              <a:spcBef>
-                <a:spcPts val="0"/>
-              </a:spcBef>
-              <a:spcAft>
-                <a:spcPts val="0"/>
-              </a:spcAft>
-              <a:buClrTx/>
-              <a:buSzTx/>
-              <a:buFontTx/>
-              <a:buNone/>
-              <a:defRPr/>
-            </a:pPr>
-            <a:r>
-              <a:rPr lang="zh-CN" altLang="en-US" sz="2400" b="0" dirty="0">
-                <a:solidFill>
-                  <a:schemeClr val="bg1"/>
-                </a:solidFill>
-                <a:latin typeface="微软雅黑" panose="020B0503020204020204" charset="-122"/>
-                <a:ea typeface="微软雅黑" panose="020B0503020204020204" charset="-122"/>
-              </a:rPr>
-              <a:t>多年来，</a:t>
-            </a:r>
-            <a:r>
-              <a:rPr lang="zh-CN" altLang="en-US" dirty="0">
-                <a:solidFill>
-                  <a:schemeClr val="bg1"/>
-                </a:solidFill>
-                <a:latin typeface="微软雅黑" panose="020B0503020204020204" charset="-122"/>
-                <a:ea typeface="微软雅黑" panose="020B0503020204020204" charset="-122"/>
-                <a:sym typeface="+mn-ea"/>
-              </a:rPr>
-              <a:t>凭借领先的经营管理与创新的科技产品，</a:t>
-            </a:r>
-            <a:r>
-              <a:rPr lang="en-US" altLang="zh-CN" sz="2400" b="0" dirty="0">
-                <a:solidFill>
-                  <a:schemeClr val="bg1"/>
-                </a:solidFill>
-                <a:latin typeface="微软雅黑" panose="020B0503020204020204" charset="-122"/>
-                <a:ea typeface="微软雅黑" panose="020B0503020204020204" charset="-122"/>
-              </a:rPr>
-              <a:t>TCL</a:t>
-            </a:r>
-            <a:r>
-              <a:rPr lang="zh-CN" altLang="en-US" sz="2400" b="0" dirty="0">
-                <a:solidFill>
-                  <a:schemeClr val="bg1"/>
-                </a:solidFill>
-                <a:latin typeface="微软雅黑" panose="020B0503020204020204" charset="-122"/>
-                <a:ea typeface="微软雅黑" panose="020B0503020204020204" charset="-122"/>
-              </a:rPr>
-              <a:t>在全球市场的布局和产品销量都实现了持续增长，并取得了一系列令人瞩目的成就。</a:t>
-            </a:r>
-            <a:endParaRPr lang="zh-CN" altLang="en-US" sz="2400" b="0" dirty="0">
-              <a:solidFill>
-                <a:schemeClr val="bg1"/>
-              </a:solidFill>
-              <a:latin typeface="微软雅黑" panose="020B0503020204020204" charset="-122"/>
-              <a:ea typeface="微软雅黑" panose="020B0503020204020204" charset="-122"/>
-            </a:endParaRPr>
-          </a:p>
-          <a:p>
             <a:endParaRPr kumimoji="1" lang="zh-CN" altLang="en-US" dirty="0"/>
           </a:p>
         </p:txBody>
@@ -2042,72 +1976,6 @@
           <a:bodyPr/>
           <a:lstStyle/>
           <a:p>
-            <a:pPr marL="0" marR="0" lvl="0" indent="0" algn="l" defTabSz="457200" rtl="0" eaLnBrk="1" fontAlgn="auto" latinLnBrk="0" hangingPunct="1">
-              <a:lnSpc>
-                <a:spcPct val="118000"/>
-              </a:lnSpc>
-              <a:spcBef>
-                <a:spcPts val="0"/>
-              </a:spcBef>
-              <a:spcAft>
-                <a:spcPts val="0"/>
-              </a:spcAft>
-              <a:buClrTx/>
-              <a:buSzTx/>
-              <a:buFontTx/>
-              <a:buNone/>
-              <a:defRPr/>
-            </a:pPr>
-            <a:r>
-              <a:rPr lang="zh-CN" altLang="en-US" sz="2400" b="0" dirty="0">
-                <a:solidFill>
-                  <a:schemeClr val="bg1"/>
-                </a:solidFill>
-                <a:latin typeface="微软雅黑" panose="020B0503020204020204" charset="-122"/>
-                <a:ea typeface="微软雅黑" panose="020B0503020204020204" charset="-122"/>
-              </a:rPr>
-              <a:t>多年来，</a:t>
-            </a:r>
-            <a:r>
-              <a:rPr lang="zh-CN" altLang="en-US" dirty="0">
-                <a:solidFill>
-                  <a:schemeClr val="bg1"/>
-                </a:solidFill>
-                <a:latin typeface="微软雅黑" panose="020B0503020204020204" charset="-122"/>
-                <a:ea typeface="微软雅黑" panose="020B0503020204020204" charset="-122"/>
-                <a:sym typeface="+mn-ea"/>
-              </a:rPr>
-              <a:t>凭借领先的经营管理与创新的科技产品，</a:t>
-            </a:r>
-            <a:r>
-              <a:rPr lang="en-US" altLang="zh-CN" sz="2400" b="0" dirty="0">
-                <a:solidFill>
-                  <a:schemeClr val="bg1"/>
-                </a:solidFill>
-                <a:latin typeface="微软雅黑" panose="020B0503020204020204" charset="-122"/>
-                <a:ea typeface="微软雅黑" panose="020B0503020204020204" charset="-122"/>
-              </a:rPr>
-              <a:t>TCL</a:t>
-            </a:r>
-            <a:r>
-              <a:rPr lang="zh-CN" altLang="en-US" sz="2400" b="0" dirty="0">
-                <a:solidFill>
-                  <a:schemeClr val="bg1"/>
-                </a:solidFill>
-                <a:latin typeface="微软雅黑" panose="020B0503020204020204" charset="-122"/>
-                <a:ea typeface="微软雅黑" panose="020B0503020204020204" charset="-122"/>
-              </a:rPr>
-              <a:t>在全球市场的布局和产品销量都实现了持续增长，并取得了一系列令人瞩目的成就。</a:t>
-            </a:r>
-            <a:endParaRPr lang="zh-CN" altLang="en-US" sz="2400" b="0" dirty="0">
-              <a:solidFill>
-                <a:schemeClr val="bg1"/>
-              </a:solidFill>
-              <a:latin typeface="微软雅黑" panose="020B0503020204020204" charset="-122"/>
-              <a:ea typeface="微软雅黑" panose="020B0503020204020204" charset="-122"/>
-            </a:endParaRPr>
-          </a:p>
-          <a:p>
             <a:endParaRPr kumimoji="1" lang="zh-CN" altLang="en-US" dirty="0"/>
           </a:p>
         </p:txBody>
@@ -2169,72 +2037,6 @@
           <a:bodyPr/>
           <a:lstStyle/>
           <a:p>
-            <a:pPr marL="0" marR="0" lvl="0" indent="0" algn="l" defTabSz="457200" rtl="0" eaLnBrk="1" fontAlgn="auto" latinLnBrk="0" hangingPunct="1">
-              <a:lnSpc>
-                <a:spcPct val="118000"/>
-              </a:lnSpc>
-              <a:spcBef>
-                <a:spcPts val="0"/>
-              </a:spcBef>
-              <a:spcAft>
-                <a:spcPts val="0"/>
-              </a:spcAft>
-              <a:buClrTx/>
-              <a:buSzTx/>
-              <a:buFontTx/>
-              <a:buNone/>
-              <a:defRPr/>
-            </a:pPr>
-            <a:r>
-              <a:rPr lang="zh-CN" altLang="en-US" sz="2400" b="0" dirty="0">
-                <a:solidFill>
-                  <a:schemeClr val="bg1"/>
-                </a:solidFill>
-                <a:latin typeface="微软雅黑" panose="020B0503020204020204" charset="-122"/>
-                <a:ea typeface="微软雅黑" panose="020B0503020204020204" charset="-122"/>
-              </a:rPr>
-              <a:t>多年来，</a:t>
-            </a:r>
-            <a:r>
-              <a:rPr lang="zh-CN" altLang="en-US" dirty="0">
-                <a:solidFill>
-                  <a:schemeClr val="bg1"/>
-                </a:solidFill>
-                <a:latin typeface="微软雅黑" panose="020B0503020204020204" charset="-122"/>
-                <a:ea typeface="微软雅黑" panose="020B0503020204020204" charset="-122"/>
-                <a:sym typeface="+mn-ea"/>
-              </a:rPr>
-              <a:t>凭借领先的经营管理与创新的科技产品，</a:t>
-            </a:r>
-            <a:r>
-              <a:rPr lang="en-US" altLang="zh-CN" sz="2400" b="0" dirty="0">
-                <a:solidFill>
-                  <a:schemeClr val="bg1"/>
-                </a:solidFill>
-                <a:latin typeface="微软雅黑" panose="020B0503020204020204" charset="-122"/>
-                <a:ea typeface="微软雅黑" panose="020B0503020204020204" charset="-122"/>
-              </a:rPr>
-              <a:t>TCL</a:t>
-            </a:r>
-            <a:r>
-              <a:rPr lang="zh-CN" altLang="en-US" sz="2400" b="0" dirty="0">
-                <a:solidFill>
-                  <a:schemeClr val="bg1"/>
-                </a:solidFill>
-                <a:latin typeface="微软雅黑" panose="020B0503020204020204" charset="-122"/>
-                <a:ea typeface="微软雅黑" panose="020B0503020204020204" charset="-122"/>
-              </a:rPr>
-              <a:t>在全球市场的布局和产品销量都实现了持续增长，并取得了一系列令人瞩目的成就。</a:t>
-            </a:r>
-            <a:endParaRPr lang="zh-CN" altLang="en-US" sz="2400" b="0" dirty="0">
-              <a:solidFill>
-                <a:schemeClr val="bg1"/>
-              </a:solidFill>
-              <a:latin typeface="微软雅黑" panose="020B0503020204020204" charset="-122"/>
-              <a:ea typeface="微软雅黑" panose="020B0503020204020204" charset="-122"/>
-            </a:endParaRPr>
-          </a:p>
-          <a:p>
             <a:endParaRPr kumimoji="1" lang="zh-CN" altLang="en-US" dirty="0"/>
           </a:p>
         </p:txBody>
@@ -2295,72 +2097,6 @@
         <p:txBody>
           <a:bodyPr/>
           <a:lstStyle/>
-          <a:p>
-            <a:pPr marL="0" marR="0" lvl="0" indent="0" algn="l" defTabSz="457200" rtl="0" eaLnBrk="1" fontAlgn="auto" latinLnBrk="0" hangingPunct="1">
-              <a:lnSpc>
-                <a:spcPct val="118000"/>
-              </a:lnSpc>
-              <a:spcBef>
-                <a:spcPts val="0"/>
-              </a:spcBef>
-              <a:spcAft>
-                <a:spcPts val="0"/>
-              </a:spcAft>
-              <a:buClrTx/>
-              <a:buSzTx/>
-              <a:buFontTx/>
-              <a:buNone/>
-              <a:defRPr/>
-            </a:pPr>
-            <a:r>
-              <a:rPr lang="zh-CN" altLang="en-US" sz="2400" b="0" dirty="0">
-                <a:solidFill>
-                  <a:schemeClr val="bg1"/>
-                </a:solidFill>
-                <a:latin typeface="微软雅黑" panose="020B0503020204020204" charset="-122"/>
-                <a:ea typeface="微软雅黑" panose="020B0503020204020204" charset="-122"/>
-              </a:rPr>
-              <a:t>多年来，</a:t>
-            </a:r>
-            <a:r>
-              <a:rPr lang="zh-CN" altLang="en-US" dirty="0">
-                <a:solidFill>
-                  <a:schemeClr val="bg1"/>
-                </a:solidFill>
-                <a:latin typeface="微软雅黑" panose="020B0503020204020204" charset="-122"/>
-                <a:ea typeface="微软雅黑" panose="020B0503020204020204" charset="-122"/>
-                <a:sym typeface="+mn-ea"/>
-              </a:rPr>
-              <a:t>凭借领先的经营管理与创新的科技产品，</a:t>
-            </a:r>
-            <a:r>
-              <a:rPr lang="en-US" altLang="zh-CN" sz="2400" b="0" dirty="0">
-                <a:solidFill>
-                  <a:schemeClr val="bg1"/>
-                </a:solidFill>
-                <a:latin typeface="微软雅黑" panose="020B0503020204020204" charset="-122"/>
-                <a:ea typeface="微软雅黑" panose="020B0503020204020204" charset="-122"/>
-              </a:rPr>
-              <a:t>TCL</a:t>
-            </a:r>
-            <a:r>
-              <a:rPr lang="zh-CN" altLang="en-US" sz="2400" b="0" dirty="0">
-                <a:solidFill>
-                  <a:schemeClr val="bg1"/>
-                </a:solidFill>
-                <a:latin typeface="微软雅黑" panose="020B0503020204020204" charset="-122"/>
-                <a:ea typeface="微软雅黑" panose="020B0503020204020204" charset="-122"/>
-              </a:rPr>
-              <a:t>在全球市场的布局和产品销量都实现了持续增长，并取得了一系列令人瞩目的成就。</a:t>
-            </a:r>
-            <a:endParaRPr lang="zh-CN" altLang="en-US" sz="2400" b="0" dirty="0">
-              <a:solidFill>
-                <a:schemeClr val="bg1"/>
-              </a:solidFill>
-              <a:latin typeface="微软雅黑" panose="020B0503020204020204" charset="-122"/>
-              <a:ea typeface="微软雅黑" panose="020B0503020204020204" charset="-122"/>
-            </a:endParaRPr>
-          </a:p>
           <a:p>
             <a:endParaRPr kumimoji="1" lang="zh-CN" altLang="en-US" dirty="0"/>
           </a:p>

</xml_diff>